<commit_message>
Add per-SKU PPT: 2026-08-24_H0883004_S_CUMainlandMacau365D18GB.pptx
</commit_message>
<xml_diff>
--- a/ppt/2026-08-24_H0883004_S_CUMainlandMacau365D18GB.pptx
+++ b/ppt/2026-08-24_H0883004_S_CUMainlandMacau365D18GB.pptx
@@ -1036,13 +1036,102 @@
       </p:sp>
       <p:sp>
         <p:nvSpPr>
-          <p:cNvPr id="7" name="Text 5"/>
+          <p:cNvPr id="7" name="Shape 5"/>
           <p:cNvSpPr/>
           <p:nvPr/>
         </p:nvSpPr>
         <p:spPr>
           <a:xfrm>
             <a:off x="457200" y="1051560"/>
+            <a:ext cx="5120640" cy="4663440"/>
+          </a:xfrm>
+          <a:prstGeom prst="roundRect">
+            <a:avLst>
+              <a:gd name="adj" fmla="val 1569"/>
+            </a:avLst>
+          </a:prstGeom>
+          <a:solidFill>
+            <a:srgbClr val="FFFFFF"/>
+          </a:solidFill>
+          <a:ln w="12700">
+            <a:solidFill>
+              <a:srgbClr val="E5E7EB"/>
+            </a:solidFill>
+            <a:prstDash val="solid"/>
+          </a:ln>
+        </p:spPr>
+      </p:sp>
+      <p:pic>
+        <p:nvPicPr>
+          <p:cNvPr id="8" name="Image 0" descr="/home/snkwok/newsfeed-scan/ppt_assets/product_sim365_full.jpg">    </p:cNvPr>
+          <p:cNvPicPr>
+            <a:picLocks noChangeAspect="1"/>
+          </p:cNvPicPr>
+          <p:nvPr/>
+        </p:nvPicPr>
+        <p:blipFill>
+          <a:blip r:embed="rId1"/>
+          <a:srcRect l="0" r="0" t="0" b="0"/>
+          <a:stretch/>
+        </p:blipFill>
+        <p:spPr>
+          <a:xfrm>
+            <a:off x="685800" y="1234440"/>
+            <a:ext cx="4663440" cy="3977640"/>
+          </a:xfrm>
+          <a:prstGeom prst="rect">
+            <a:avLst/>
+          </a:prstGeom>
+        </p:spPr>
+      </p:pic>
+      <p:sp>
+        <p:nvSpPr>
+          <p:cNvPr id="9" name="Text 6"/>
+          <p:cNvSpPr/>
+          <p:nvPr/>
+        </p:nvSpPr>
+        <p:spPr>
+          <a:xfrm>
+            <a:off x="457200" y="5742432"/>
+            <a:ext cx="5120640" cy="274320"/>
+          </a:xfrm>
+          <a:prstGeom prst="rect">
+            <a:avLst/>
+          </a:prstGeom>
+          <a:noFill/>
+          <a:ln/>
+        </p:spPr>
+        <p:txBody>
+          <a:bodyPr wrap="square" rtlCol="0" anchor="ctr"/>
+          <a:lstStyle/>
+          <a:p>
+            <a:pPr algn="ctr" indent="0" marL="0">
+              <a:buNone/>
+            </a:pPr>
+            <a:r>
+              <a:rPr lang="en-US" sz="1100" dirty="0">
+                <a:solidFill>
+                  <a:srgbClr val="6B7280"/>
+                </a:solidFill>
+                <a:latin typeface="Microsoft JhengHei" pitchFamily="34" charset="0"/>
+                <a:ea typeface="Microsoft JhengHei" pitchFamily="34" charset="-122"/>
+                <a:cs typeface="Microsoft JhengHei" pitchFamily="34" charset="-120"/>
+              </a:rPr>
+              <a:t>📦 HKTVmall 產品圖（參考）</a:t>
+            </a:r>
+            <a:endParaRPr lang="en-US" sz="1100" dirty="0"/>
+          </a:p>
+        </p:txBody>
+      </p:sp>
+      <p:sp>
+        <p:nvSpPr>
+          <p:cNvPr id="10" name="Text 7"/>
+          <p:cNvSpPr/>
+          <p:nvPr/>
+        </p:nvSpPr>
+        <p:spPr>
+          <a:xfrm>
+            <a:off x="5852160" y="1051560"/>
             <a:ext cx="731520" cy="731520"/>
           </a:xfrm>
           <a:prstGeom prst="rect">
@@ -1075,14 +1164,14 @@
       </p:sp>
       <p:sp>
         <p:nvSpPr>
-          <p:cNvPr id="8" name="Text 6"/>
-          <p:cNvSpPr/>
-          <p:nvPr/>
-        </p:nvSpPr>
-        <p:spPr>
-          <a:xfrm>
-            <a:off x="1234440" y="1115568"/>
-            <a:ext cx="7315200" cy="685800"/>
+          <p:cNvPr id="11" name="Text 8"/>
+          <p:cNvSpPr/>
+          <p:nvPr/>
+        </p:nvSpPr>
+        <p:spPr>
+          <a:xfrm>
+            <a:off x="6629400" y="1115568"/>
+            <a:ext cx="5120640" cy="685800"/>
           </a:xfrm>
           <a:prstGeom prst="rect">
             <a:avLst/>
@@ -1114,14 +1203,14 @@
       </p:sp>
       <p:sp>
         <p:nvSpPr>
-          <p:cNvPr id="9" name="Text 7"/>
-          <p:cNvSpPr/>
-          <p:nvPr/>
-        </p:nvSpPr>
-        <p:spPr>
-          <a:xfrm>
-            <a:off x="1234440" y="1783080"/>
-            <a:ext cx="5486400" cy="320040"/>
+          <p:cNvPr id="12" name="Text 9"/>
+          <p:cNvSpPr/>
+          <p:nvPr/>
+        </p:nvSpPr>
+        <p:spPr>
+          <a:xfrm>
+            <a:off x="6629400" y="1783080"/>
+            <a:ext cx="5120640" cy="320040"/>
           </a:xfrm>
           <a:prstGeom prst="rect">
             <a:avLst/>
@@ -1153,20 +1242,22 @@
       </p:sp>
       <p:sp>
         <p:nvSpPr>
-          <p:cNvPr id="10" name="Text 8"/>
-          <p:cNvSpPr/>
-          <p:nvPr/>
-        </p:nvSpPr>
-        <p:spPr>
-          <a:xfrm>
-            <a:off x="1234440" y="2121408"/>
-            <a:ext cx="4206240" cy="320040"/>
-          </a:xfrm>
-          <a:prstGeom prst="rect">
-            <a:avLst/>
-          </a:prstGeom>
-          <a:solidFill>
-            <a:srgbClr val="CCFBF1"/>
+          <p:cNvPr id="13" name="Text 10">
+            <a:hlinkClick r:id="rId2" tooltip="開啟 HKTVmall 產品頁"/>
+          </p:cNvPr>
+          <p:cNvSpPr/>
+          <p:nvPr/>
+        </p:nvSpPr>
+        <p:spPr>
+          <a:xfrm>
+            <a:off x="6629400" y="2121408"/>
+            <a:ext cx="5029200" cy="347472"/>
+          </a:xfrm>
+          <a:prstGeom prst="rect">
+            <a:avLst/>
+          </a:prstGeom>
+          <a:solidFill>
+            <a:srgbClr val="0F766E"/>
           </a:solidFill>
           <a:ln/>
         </p:spPr>
@@ -1178,13 +1269,20 @@
               <a:buNone/>
             </a:pPr>
             <a:r>
-              <a:rPr lang="en-US" sz="1200" dirty="0">
+              <a:rPr lang="en-US" sz="1200" b="1" u="sng" dirty="0">
                 <a:solidFill>
-                  <a:srgbClr val="0F766E"/>
+                  <a:srgbClr val="FFFFFF"/>
                 </a:solidFill>
                 <a:latin typeface="Consolas" pitchFamily="34" charset="0"/>
                 <a:ea typeface="Consolas" pitchFamily="34" charset="-122"/>
                 <a:cs typeface="Consolas" pitchFamily="34" charset="-120"/>
+                <a:hlinkClick r:id="rId2" invalidUrl="" action="" tgtFrame="" tooltip="開啟 HKTVmall 產品頁" history="1" highlightClick="0" endSnd="0">
+                  <a:extLst>
+                    <a:ext uri="{A12FA001-AC4F-418D-AE19-62706E023703}">
+                      <ahyp:hlinkClr xmlns:ahyp="http://schemas.microsoft.com/office/drawing/2018/hyperlinkcolor" val="tx"/>
+                    </a:ext>
+                  </a:extLst>
+                </a:hlinkClick>
               </a:rPr>
               <a:t>H0883004_S_CUMainlandMacau365D18GB</a:t>
             </a:r>
@@ -1194,14 +1292,53 @@
       </p:sp>
       <p:sp>
         <p:nvSpPr>
-          <p:cNvPr id="11" name="Shape 9"/>
-          <p:cNvSpPr/>
-          <p:nvPr/>
-        </p:nvSpPr>
-        <p:spPr>
-          <a:xfrm>
-            <a:off x="457200" y="2697480"/>
-            <a:ext cx="1645920" cy="960120"/>
+          <p:cNvPr id="14" name="Text 11"/>
+          <p:cNvSpPr/>
+          <p:nvPr/>
+        </p:nvSpPr>
+        <p:spPr>
+          <a:xfrm>
+            <a:off x="6629400" y="2496312"/>
+            <a:ext cx="5029200" cy="256032"/>
+          </a:xfrm>
+          <a:prstGeom prst="rect">
+            <a:avLst/>
+          </a:prstGeom>
+          <a:noFill/>
+          <a:ln/>
+        </p:spPr>
+        <p:txBody>
+          <a:bodyPr wrap="square" rtlCol="0" anchor="ctr"/>
+          <a:lstStyle/>
+          <a:p>
+            <a:pPr indent="0" marL="0">
+              <a:buNone/>
+            </a:pPr>
+            <a:r>
+              <a:rPr lang="en-US" sz="950" dirty="0">
+                <a:solidFill>
+                  <a:srgbClr val="6B7280"/>
+                </a:solidFill>
+                <a:latin typeface="Microsoft JhengHei" pitchFamily="34" charset="0"/>
+                <a:ea typeface="Microsoft JhengHei" pitchFamily="34" charset="-122"/>
+                <a:cs typeface="Microsoft JhengHei" pitchFamily="34" charset="-120"/>
+              </a:rPr>
+              <a:t>🔗 按 SKU 開啟 HKTVmall 產品頁</a:t>
+            </a:r>
+            <a:endParaRPr lang="en-US" sz="950" dirty="0"/>
+          </a:p>
+        </p:txBody>
+      </p:sp>
+      <p:sp>
+        <p:nvSpPr>
+          <p:cNvPr id="15" name="Shape 12"/>
+          <p:cNvSpPr/>
+          <p:nvPr/>
+        </p:nvSpPr>
+        <p:spPr>
+          <a:xfrm>
+            <a:off x="5852160" y="2880360"/>
+            <a:ext cx="1737360" cy="960120"/>
           </a:xfrm>
           <a:prstGeom prst="roundRect">
             <a:avLst>
@@ -1221,14 +1358,14 @@
       </p:sp>
       <p:sp>
         <p:nvSpPr>
-          <p:cNvPr id="12" name="Text 10"/>
-          <p:cNvSpPr/>
-          <p:nvPr/>
-        </p:nvSpPr>
-        <p:spPr>
-          <a:xfrm>
-            <a:off x="457200" y="2816352"/>
-            <a:ext cx="1645920" cy="256032"/>
+          <p:cNvPr id="16" name="Text 13"/>
+          <p:cNvSpPr/>
+          <p:nvPr/>
+        </p:nvSpPr>
+        <p:spPr>
+          <a:xfrm>
+            <a:off x="5852160" y="2999232"/>
+            <a:ext cx="1737360" cy="256032"/>
           </a:xfrm>
           <a:prstGeom prst="rect">
             <a:avLst/>
@@ -1260,14 +1397,14 @@
       </p:sp>
       <p:sp>
         <p:nvSpPr>
-          <p:cNvPr id="13" name="Text 11"/>
-          <p:cNvSpPr/>
-          <p:nvPr/>
-        </p:nvSpPr>
-        <p:spPr>
-          <a:xfrm>
-            <a:off x="457200" y="3072384"/>
-            <a:ext cx="1645920" cy="411480"/>
+          <p:cNvPr id="17" name="Text 14"/>
+          <p:cNvSpPr/>
+          <p:nvPr/>
+        </p:nvSpPr>
+        <p:spPr>
+          <a:xfrm>
+            <a:off x="5852160" y="3255264"/>
+            <a:ext cx="1737360" cy="411480"/>
           </a:xfrm>
           <a:prstGeom prst="rect">
             <a:avLst/>
@@ -1283,7 +1420,7 @@
               <a:buNone/>
             </a:pPr>
             <a:r>
-              <a:rPr lang="en-US" sz="1700" b="1" dirty="0">
+              <a:rPr lang="en-US" sz="1600" b="1" dirty="0">
                 <a:solidFill>
                   <a:srgbClr val="0F766E"/>
                 </a:solidFill>
@@ -1293,20 +1430,20 @@
               </a:rPr>
               <a:t>$143.29</a:t>
             </a:r>
-            <a:endParaRPr lang="en-US" sz="1700" dirty="0"/>
-          </a:p>
-        </p:txBody>
-      </p:sp>
-      <p:sp>
-        <p:nvSpPr>
-          <p:cNvPr id="14" name="Shape 12"/>
-          <p:cNvSpPr/>
-          <p:nvPr/>
-        </p:nvSpPr>
-        <p:spPr>
-          <a:xfrm>
-            <a:off x="2240280" y="2697480"/>
-            <a:ext cx="1645920" cy="960120"/>
+            <a:endParaRPr lang="en-US" sz="1600" dirty="0"/>
+          </a:p>
+        </p:txBody>
+      </p:sp>
+      <p:sp>
+        <p:nvSpPr>
+          <p:cNvPr id="18" name="Shape 15"/>
+          <p:cNvSpPr/>
+          <p:nvPr/>
+        </p:nvSpPr>
+        <p:spPr>
+          <a:xfrm>
+            <a:off x="7726680" y="2880360"/>
+            <a:ext cx="1737360" cy="960120"/>
           </a:xfrm>
           <a:prstGeom prst="roundRect">
             <a:avLst>
@@ -1326,14 +1463,14 @@
       </p:sp>
       <p:sp>
         <p:nvSpPr>
-          <p:cNvPr id="15" name="Text 13"/>
-          <p:cNvSpPr/>
-          <p:nvPr/>
-        </p:nvSpPr>
-        <p:spPr>
-          <a:xfrm>
-            <a:off x="2240280" y="2816352"/>
-            <a:ext cx="1645920" cy="256032"/>
+          <p:cNvPr id="19" name="Text 16"/>
+          <p:cNvSpPr/>
+          <p:nvPr/>
+        </p:nvSpPr>
+        <p:spPr>
+          <a:xfrm>
+            <a:off x="7726680" y="2999232"/>
+            <a:ext cx="1737360" cy="256032"/>
           </a:xfrm>
           <a:prstGeom prst="rect">
             <a:avLst/>
@@ -1365,14 +1502,14 @@
       </p:sp>
       <p:sp>
         <p:nvSpPr>
-          <p:cNvPr id="16" name="Text 14"/>
-          <p:cNvSpPr/>
-          <p:nvPr/>
-        </p:nvSpPr>
-        <p:spPr>
-          <a:xfrm>
-            <a:off x="2240280" y="3072384"/>
-            <a:ext cx="1645920" cy="411480"/>
+          <p:cNvPr id="20" name="Text 17"/>
+          <p:cNvSpPr/>
+          <p:nvPr/>
+        </p:nvSpPr>
+        <p:spPr>
+          <a:xfrm>
+            <a:off x="7726680" y="3255264"/>
+            <a:ext cx="1737360" cy="411480"/>
           </a:xfrm>
           <a:prstGeom prst="rect">
             <a:avLst/>
@@ -1388,7 +1525,7 @@
               <a:buNone/>
             </a:pPr>
             <a:r>
-              <a:rPr lang="en-US" sz="1700" b="1" dirty="0">
+              <a:rPr lang="en-US" sz="1600" b="1" dirty="0">
                 <a:solidFill>
                   <a:srgbClr val="115E59"/>
                 </a:solidFill>
@@ -1398,20 +1535,20 @@
               </a:rPr>
               <a:t>$20,491</a:t>
             </a:r>
-            <a:endParaRPr lang="en-US" sz="1700" dirty="0"/>
-          </a:p>
-        </p:txBody>
-      </p:sp>
-      <p:sp>
-        <p:nvSpPr>
-          <p:cNvPr id="17" name="Shape 15"/>
-          <p:cNvSpPr/>
-          <p:nvPr/>
-        </p:nvSpPr>
-        <p:spPr>
-          <a:xfrm>
-            <a:off x="4023360" y="2697480"/>
-            <a:ext cx="1645920" cy="960120"/>
+            <a:endParaRPr lang="en-US" sz="1600" dirty="0"/>
+          </a:p>
+        </p:txBody>
+      </p:sp>
+      <p:sp>
+        <p:nvSpPr>
+          <p:cNvPr id="21" name="Shape 18"/>
+          <p:cNvSpPr/>
+          <p:nvPr/>
+        </p:nvSpPr>
+        <p:spPr>
+          <a:xfrm>
+            <a:off x="9601200" y="2880360"/>
+            <a:ext cx="1737360" cy="960120"/>
           </a:xfrm>
           <a:prstGeom prst="roundRect">
             <a:avLst>
@@ -1431,14 +1568,14 @@
       </p:sp>
       <p:sp>
         <p:nvSpPr>
-          <p:cNvPr id="18" name="Text 16"/>
-          <p:cNvSpPr/>
-          <p:nvPr/>
-        </p:nvSpPr>
-        <p:spPr>
-          <a:xfrm>
-            <a:off x="4023360" y="2816352"/>
-            <a:ext cx="1645920" cy="256032"/>
+          <p:cNvPr id="22" name="Text 19"/>
+          <p:cNvSpPr/>
+          <p:nvPr/>
+        </p:nvSpPr>
+        <p:spPr>
+          <a:xfrm>
+            <a:off x="9601200" y="2999232"/>
+            <a:ext cx="1737360" cy="256032"/>
           </a:xfrm>
           <a:prstGeom prst="rect">
             <a:avLst/>
@@ -1470,14 +1607,14 @@
       </p:sp>
       <p:sp>
         <p:nvSpPr>
-          <p:cNvPr id="19" name="Text 17"/>
-          <p:cNvSpPr/>
-          <p:nvPr/>
-        </p:nvSpPr>
-        <p:spPr>
-          <a:xfrm>
-            <a:off x="4023360" y="3072384"/>
-            <a:ext cx="1645920" cy="411480"/>
+          <p:cNvPr id="23" name="Text 20"/>
+          <p:cNvSpPr/>
+          <p:nvPr/>
+        </p:nvSpPr>
+        <p:spPr>
+          <a:xfrm>
+            <a:off x="9601200" y="3255264"/>
+            <a:ext cx="1737360" cy="411480"/>
           </a:xfrm>
           <a:prstGeom prst="rect">
             <a:avLst/>
@@ -1493,7 +1630,7 @@
               <a:buNone/>
             </a:pPr>
             <a:r>
-              <a:rPr lang="en-US" sz="1700" b="1" dirty="0">
+              <a:rPr lang="en-US" sz="1600" b="1" dirty="0">
                 <a:solidFill>
                   <a:srgbClr val="F59E0B"/>
                 </a:solidFill>
@@ -1503,19 +1640,19 @@
               </a:rPr>
               <a:t>143 件</a:t>
             </a:r>
-            <a:endParaRPr lang="en-US" sz="1700" dirty="0"/>
-          </a:p>
-        </p:txBody>
-      </p:sp>
-      <p:sp>
-        <p:nvSpPr>
-          <p:cNvPr id="20" name="Text 18"/>
-          <p:cNvSpPr/>
-          <p:nvPr/>
-        </p:nvSpPr>
-        <p:spPr>
-          <a:xfrm>
-            <a:off x="457200" y="3931920"/>
+            <a:endParaRPr lang="en-US" sz="1600" dirty="0"/>
+          </a:p>
+        </p:txBody>
+      </p:sp>
+      <p:sp>
+        <p:nvSpPr>
+          <p:cNvPr id="24" name="Text 21"/>
+          <p:cNvSpPr/>
+          <p:nvPr/>
+        </p:nvSpPr>
+        <p:spPr>
+          <a:xfrm>
+            <a:off x="5852160" y="4069080"/>
             <a:ext cx="3657600" cy="320040"/>
           </a:xfrm>
           <a:prstGeom prst="rect">
@@ -1548,14 +1685,14 @@
       </p:sp>
       <p:sp>
         <p:nvSpPr>
-          <p:cNvPr id="21" name="Text 19"/>
-          <p:cNvSpPr/>
-          <p:nvPr/>
-        </p:nvSpPr>
-        <p:spPr>
-          <a:xfrm>
-            <a:off x="502920" y="4297680"/>
-            <a:ext cx="5394960" cy="548640"/>
+          <p:cNvPr id="25" name="Text 22"/>
+          <p:cNvSpPr/>
+          <p:nvPr/>
+        </p:nvSpPr>
+        <p:spPr>
+          <a:xfrm>
+            <a:off x="5897880" y="4434840"/>
+            <a:ext cx="5760720" cy="548640"/>
           </a:xfrm>
           <a:prstGeom prst="rect">
             <a:avLst/>
@@ -1587,14 +1724,14 @@
       </p:sp>
       <p:sp>
         <p:nvSpPr>
-          <p:cNvPr id="22" name="Text 20"/>
-          <p:cNvSpPr/>
-          <p:nvPr/>
-        </p:nvSpPr>
-        <p:spPr>
-          <a:xfrm>
-            <a:off x="502920" y="4864608"/>
-            <a:ext cx="5394960" cy="548640"/>
+          <p:cNvPr id="26" name="Text 23"/>
+          <p:cNvSpPr/>
+          <p:nvPr/>
+        </p:nvSpPr>
+        <p:spPr>
+          <a:xfrm>
+            <a:off x="5897880" y="5001768"/>
+            <a:ext cx="5760720" cy="548640"/>
           </a:xfrm>
           <a:prstGeom prst="rect">
             <a:avLst/>
@@ -1626,14 +1763,14 @@
       </p:sp>
       <p:sp>
         <p:nvSpPr>
-          <p:cNvPr id="23" name="Text 21"/>
-          <p:cNvSpPr/>
-          <p:nvPr/>
-        </p:nvSpPr>
-        <p:spPr>
-          <a:xfrm>
-            <a:off x="502920" y="5431536"/>
-            <a:ext cx="5394960" cy="548640"/>
+          <p:cNvPr id="27" name="Text 24"/>
+          <p:cNvSpPr/>
+          <p:nvPr/>
+        </p:nvSpPr>
+        <p:spPr>
+          <a:xfrm>
+            <a:off x="5897880" y="5568696"/>
+            <a:ext cx="5760720" cy="548640"/>
           </a:xfrm>
           <a:prstGeom prst="rect">
             <a:avLst/>
@@ -1665,91 +1802,36 @@
       </p:sp>
       <p:sp>
         <p:nvSpPr>
-          <p:cNvPr id="24" name="Shape 22"/>
-          <p:cNvSpPr/>
-          <p:nvPr/>
-        </p:nvSpPr>
-        <p:spPr>
-          <a:xfrm>
-            <a:off x="6263640" y="1051560"/>
-            <a:ext cx="5486400" cy="3090672"/>
+          <p:cNvPr id="28" name="Shape 25"/>
+          <p:cNvSpPr/>
+          <p:nvPr/>
+        </p:nvSpPr>
+        <p:spPr>
+          <a:xfrm>
+            <a:off x="5852160" y="5943600"/>
+            <a:ext cx="5852160" cy="566928"/>
           </a:xfrm>
           <a:prstGeom prst="roundRect">
             <a:avLst>
-              <a:gd name="adj" fmla="val 1775"/>
+              <a:gd name="adj" fmla="val 9677"/>
             </a:avLst>
           </a:prstGeom>
           <a:solidFill>
-            <a:srgbClr val="FFFFFF"/>
-          </a:solidFill>
-          <a:ln w="12700">
-            <a:solidFill>
-              <a:srgbClr val="E5E7EB"/>
-            </a:solidFill>
-            <a:prstDash val="solid"/>
-          </a:ln>
-        </p:spPr>
-      </p:sp>
-      <p:pic>
-        <p:nvPicPr>
-          <p:cNvPr id="25" name="Image 0" descr="/home/snkwok/newsfeed-scan/ppt_assets/product_sim365_full.jpg">    </p:cNvPr>
-          <p:cNvPicPr>
-            <a:picLocks noChangeAspect="1"/>
-          </p:cNvPicPr>
-          <p:nvPr/>
-        </p:nvPicPr>
-        <p:blipFill>
-          <a:blip r:embed="rId1"/>
-          <a:srcRect l="0" r="0" t="0" b="0"/>
-          <a:stretch/>
-        </p:blipFill>
-        <p:spPr>
-          <a:xfrm>
-            <a:off x="6446520" y="1207008"/>
-            <a:ext cx="5120640" cy="2880360"/>
-          </a:xfrm>
-          <a:prstGeom prst="rect">
-            <a:avLst/>
-          </a:prstGeom>
-        </p:spPr>
-      </p:pic>
-      <p:sp>
-        <p:nvSpPr>
-          <p:cNvPr id="26" name="Shape 23"/>
-          <p:cNvSpPr/>
-          <p:nvPr/>
-        </p:nvSpPr>
-        <p:spPr>
-          <a:xfrm>
-            <a:off x="6263640" y="4315968"/>
-            <a:ext cx="5486400" cy="1691640"/>
-          </a:xfrm>
-          <a:prstGeom prst="roundRect">
-            <a:avLst>
-              <a:gd name="adj" fmla="val 3243"/>
-            </a:avLst>
-          </a:prstGeom>
-          <a:solidFill>
-            <a:srgbClr val="FFFFFF"/>
-          </a:solidFill>
-          <a:ln w="12700">
-            <a:solidFill>
-              <a:srgbClr val="E5E7EB"/>
-            </a:solidFill>
-            <a:prstDash val="solid"/>
-          </a:ln>
-        </p:spPr>
-      </p:sp>
-      <p:sp>
-        <p:nvSpPr>
-          <p:cNvPr id="27" name="Text 24"/>
-          <p:cNvSpPr/>
-          <p:nvPr/>
-        </p:nvSpPr>
-        <p:spPr>
-          <a:xfrm>
-            <a:off x="6446520" y="4434840"/>
-            <a:ext cx="5120640" cy="274320"/>
+            <a:srgbClr val="FEF3C7"/>
+          </a:solidFill>
+          <a:ln/>
+        </p:spPr>
+      </p:sp>
+      <p:sp>
+        <p:nvSpPr>
+          <p:cNvPr id="29" name="Text 26"/>
+          <p:cNvSpPr/>
+          <p:nvPr/>
+        </p:nvSpPr>
+        <p:spPr>
+          <a:xfrm>
+            <a:off x="5989320" y="5971032"/>
+            <a:ext cx="5577840" cy="512064"/>
           </a:xfrm>
           <a:prstGeom prst="rect">
             <a:avLst/>
@@ -1765,46 +1847,7 @@
               <a:buNone/>
             </a:pPr>
             <a:r>
-              <a:rPr lang="en-US" sz="1200" b="1" dirty="0">
-                <a:solidFill>
-                  <a:srgbClr val="D97706"/>
-                </a:solidFill>
-                <a:latin typeface="Microsoft JhengHei" pitchFamily="34" charset="0"/>
-                <a:ea typeface="Microsoft JhengHei" pitchFamily="34" charset="-122"/>
-                <a:cs typeface="Microsoft JhengHei" pitchFamily="34" charset="-120"/>
-              </a:rPr>
-              <a:t>📢 社交熱度證據（YouTube）</a:t>
-            </a:r>
-            <a:endParaRPr lang="en-US" sz="1200" dirty="0"/>
-          </a:p>
-        </p:txBody>
-      </p:sp>
-      <p:sp>
-        <p:nvSpPr>
-          <p:cNvPr id="28" name="Text 25"/>
-          <p:cNvSpPr/>
-          <p:nvPr/>
-        </p:nvSpPr>
-        <p:spPr>
-          <a:xfrm>
-            <a:off x="6446520" y="4736592"/>
-            <a:ext cx="5120640" cy="914400"/>
-          </a:xfrm>
-          <a:prstGeom prst="rect">
-            <a:avLst/>
-          </a:prstGeom>
-          <a:noFill/>
-          <a:ln/>
-        </p:spPr>
-        <p:txBody>
-          <a:bodyPr wrap="square" rtlCol="0" anchor="ctr"/>
-          <a:lstStyle/>
-          <a:p>
-            <a:pPr indent="0" marL="0">
-              <a:buNone/>
-            </a:pPr>
-            <a:r>
-              <a:rPr lang="en-US" sz="1150" dirty="0">
+              <a:rPr lang="en-US" sz="950" dirty="0">
                 <a:solidFill>
                   <a:srgbClr val="1A1A2E"/>
                 </a:solidFill>
@@ -1812,22 +1855,24 @@
                 <a:ea typeface="Microsoft JhengHei" pitchFamily="34" charset="-122"/>
                 <a:cs typeface="Microsoft JhengHei" pitchFamily="34" charset="-120"/>
               </a:rPr>
-              <a:t>2026 日本旅遊 SIM/eSIM 選購攻略 1 個月前；中國聯通年卡懶人包 3 個月前；MySIM 5G 攻略 2 個月前</a:t>
-            </a:r>
-            <a:endParaRPr lang="en-US" sz="1150" dirty="0"/>
-          </a:p>
-        </p:txBody>
-      </p:sp>
-      <p:sp>
-        <p:nvSpPr>
-          <p:cNvPr id="29" name="Text 26"/>
-          <p:cNvSpPr/>
-          <p:nvPr/>
-        </p:nvSpPr>
-        <p:spPr>
-          <a:xfrm>
-            <a:off x="6446520" y="5687568"/>
-            <a:ext cx="5120640" cy="274320"/>
+              <a:t>📢 2026 日本旅遊 SIM/eSIM 選購攻略 1 個月前；中國聯通年卡懶人包 3 個月前；MySIM 5G 攻略 2 個月前</a:t>
+            </a:r>
+            <a:endParaRPr lang="en-US" sz="950" dirty="0"/>
+          </a:p>
+        </p:txBody>
+      </p:sp>
+      <p:sp>
+        <p:nvSpPr>
+          <p:cNvPr id="30" name="Text 27">
+            <a:hlinkClick r:id="rId3" tooltip="開啟 YouTube 影片"/>
+          </p:cNvPr>
+          <p:cNvSpPr/>
+          <p:nvPr/>
+        </p:nvSpPr>
+        <p:spPr>
+          <a:xfrm>
+            <a:off x="5852160" y="6144768"/>
+            <a:ext cx="5852160" cy="274320"/>
           </a:xfrm>
           <a:prstGeom prst="rect">
             <a:avLst/>
@@ -1843,23 +1888,30 @@
               <a:buNone/>
             </a:pPr>
             <a:r>
-              <a:rPr lang="en-US" sz="1050" dirty="0">
+              <a:rPr lang="en-US" sz="900" u="sng" dirty="0">
                 <a:solidFill>
                   <a:srgbClr val="0F766E"/>
                 </a:solidFill>
                 <a:latin typeface="Consolas" pitchFamily="34" charset="0"/>
                 <a:ea typeface="Consolas" pitchFamily="34" charset="-122"/>
                 <a:cs typeface="Consolas" pitchFamily="34" charset="-120"/>
+                <a:hlinkClick r:id="rId3" invalidUrl="" action="" tgtFrame="" tooltip="開啟 YouTube 影片" history="1" highlightClick="0" endSnd="0">
+                  <a:extLst>
+                    <a:ext uri="{A12FA001-AC4F-418D-AE19-62706E023703}">
+                      <ahyp:hlinkClr xmlns:ahyp="http://schemas.microsoft.com/office/drawing/2018/hyperlinkcolor" val="tx"/>
+                    </a:ext>
+                  </a:extLst>
+                </a:hlinkClick>
               </a:rPr>
-              <a:t>🔗 https://www.youtube.com/watch?v=9O2zEPzxEhE</a:t>
-            </a:r>
-            <a:endParaRPr lang="en-US" sz="1050" dirty="0"/>
-          </a:p>
-        </p:txBody>
-      </p:sp>
-      <p:sp>
-        <p:nvSpPr>
-          <p:cNvPr id="30" name="Shape 27"/>
+              <a:t>📺 https://www.youtube.com/watch?v=9O2zEPzxEhE</a:t>
+            </a:r>
+            <a:endParaRPr lang="en-US" sz="900" dirty="0"/>
+          </a:p>
+        </p:txBody>
+      </p:sp>
+      <p:sp>
+        <p:nvSpPr>
+          <p:cNvPr id="31" name="Shape 28"/>
           <p:cNvSpPr/>
           <p:nvPr/>
         </p:nvSpPr>
@@ -1879,7 +1931,7 @@
       </p:sp>
       <p:sp>
         <p:nvSpPr>
-          <p:cNvPr id="31" name="Text 28"/>
+          <p:cNvPr id="32" name="Text 29"/>
           <p:cNvSpPr/>
           <p:nvPr/>
         </p:nvSpPr>

</xml_diff>